<commit_message>
October 1 to 10: scrapbook restyle with drawn-shape stickers (interim, until Replicate is unlocked); coffee back to the brief's exact text
Co-Authored-By: Claude Opus 5.5 <noreply@anthropic.com>
Claude-Session: https://claude.ai/code/session_014HGzAbxBh54nuyJHG7tse8
</commit_message>
<xml_diff>
--- a/templates/posts/october/01-10-2026-thu-ig-coffee-myth.pptx
+++ b/templates/posts/october/01-10-2026-thu-ig-coffee-myth.pptx
@@ -508,7 +508,7 @@
           <a:lstStyle/>
           <a:p>
             <a:r>
-              <a:t>Myth slide. Sources: Hardgrove and Livesley, Urban Forestry and Urban Greening, 2016, https://doi.org/10.1016/j.ufug.2016.02.015; Summers et al., Journal of Bacteriology, 2012, https://doi.org/10.1128/JB.06637-11; US EPA, 40 CFR Part 503, https://www.ecfr.gov/current/title-40/chapter-I/subchapter-O/part-503. Photos: Photo by Stacy on Unsplash (https://unsplash.com/@stacysuxx?utm_source=sfw_social&amp;utm_medium=referral). Photo by Klim Sergeev on Unsplash (https://unsplash.com/@klimsergeev?utm_source=sfw_social&amp;utm_medium=referral). Stickers (lemon, cup, beans, seedlings, bacteria, pH strip, thermometer) are drawn PowerPoint shapes, grouped and editable.</a:t>
+              <a:t>Myth slide. Sources: Hardgrove and Livesley, Urban Forestry and Urban Greening, 2016, https://doi.org/10.1016/j.ufug.2016.02.015; Summers et al., Journal of Bacteriology, 2012, https://doi.org/10.1128/JB.06637-11; US EPA, 40 CFR Part 503, https://www.ecfr.gov/current/title-40/chapter-I/subchapter-O/part-503. Photos: Photo by Stacy on Unsplash (https://unsplash.com/@stacysuxx?utm_source=sfw_social&amp;utm_medium=referral). Photo by Klim Sergeev on Unsplash (https://unsplash.com/@klimsergeev?utm_source=sfw_social&amp;utm_medium=referral). Stickers (lemon, cup, beans, seedlings, bacteria, pH strip, thermometer) are drawn PowerPoint shapes, grouped and editable. Draft livelier copy (not in use, awaiting approval): Happy International Coffee Day ☕ Let's spill the beans.</a:t>
             </a:r>
           </a:p>
         </p:txBody>
@@ -578,7 +578,7 @@
           <a:lstStyle/>
           <a:p>
             <a:r>
-              <a:t>pH strip: universal indicator colours, 0 to 14. Lemon marks the acid end; the cup sits near neutral, as the slide says. Stickers (lemon, cup, beans, seedlings, bacteria, pH strip, thermometer) are drawn PowerPoint shapes, grouped and editable.</a:t>
+              <a:t>pH strip: universal indicator colours, 0 to 14. Lemon marks the acid end; the cup sits near neutral, as the slide says. Stickers (lemon, cup, beans, seedlings, bacteria, pH strip, thermometer) are drawn PowerPoint shapes, grouped and editable. Draft livelier copy (not in use, awaiting approval): Plot twist: your coffee took the acid with it. Brewing pulls most of the acids into your cup. The spent grounds left behind sit close to neutral pH.</a:t>
             </a:r>
           </a:p>
         </p:txBody>
@@ -648,7 +648,7 @@
           <a:lstStyle/>
           <a:p>
             <a:r>
-              <a:t>Photo: Photo by Bianca Pătrașcu on Unsplash (https://unsplash.com/@bianncapatrascu?utm_source=sfw_social&amp;utm_medium=referral). Stickers (lemon, cup, beans, seedlings, bacteria, pH strip, thermometer) are drawn PowerPoint shapes, grouped and editable.</a:t>
+              <a:t>Photo: Photo by Bianca Pătrașcu on Unsplash (https://unsplash.com/@bianncapatrascu?utm_source=sfw_social&amp;utm_medium=referral). Stickers (lemon, cup, beans, seedlings, bacteria, pH strip, thermometer) are drawn PowerPoint shapes, grouped and editable. Draft livelier copy (not in use, awaiting approval): So what's the catch? Caffeine. 😬 Leftover caffeine and chlorogenic acids are allelopathic: plant-speak for chemicals that stop seeds sprouting and roots growing.</a:t>
             </a:r>
           </a:p>
         </p:txBody>
@@ -718,7 +718,7 @@
           <a:lstStyle/>
           <a:p>
             <a:r>
-              <a:t>Photo: assets/photo/garden-vegetable-beds.jpg (Foundation library). Stickers (lemon, cup, beans, seedlings, bacteria, pH strip, thermometer) are drawn PowerPoint shapes, grouped and editable.</a:t>
+              <a:t>Photo: assets/photo/garden-vegetable-beds.jpg (Foundation library). Stickers (lemon, cup, beans, seedlings, bacteria, pH strip, thermometer) are drawn PowerPoint shapes, grouped and editable. Draft livelier copy (not in use, awaiting approval): Sprinkled straight on the garden? In trials, fresh grounds spread on beds actually slowed plant growth. 🥀</a:t>
             </a:r>
           </a:p>
         </p:txBody>
@@ -788,7 +788,7 @@
           <a:lstStyle/>
           <a:p>
             <a:r>
-              <a:t>Microscopy: assets/microscopy/sfw-amoeba-still-square.jpg (Foundation). The library has no bacteria-only image; this still shows an amoeba, a bacteria feeder. Swap in a bacteria micrograph if Wes has one [IMAGE NEEDED]. The drawn bacteria are rods with a flagellum, like Pseudomonas. Stickers (lemon, cup, beans, seedlings, bacteria, pH strip, thermometer) are drawn PowerPoint shapes, grouped and editable.</a:t>
+              <a:t>Microscopy: assets/microscopy/sfw-amoeba-still-square.jpg (Foundation). The library has no bacteria-only image; this still shows an amoeba, a bacteria feeder. Swap in a bacteria micrograph if Wes has one [IMAGE NEEDED]. The drawn bacteria are rods with a flagellum, like Pseudomonas. Stickers (lemon, cup, beans, seedlings, bacteria, pH strip, thermometer) are drawn PowerPoint shapes, grouped and editable. Draft livelier copy (not in use, awaiting approval): Enter the compost crew. 🦠 Composting breaks caffeine down. Some soil bacteria eat it for breakfast, lunch and dinner: Pseudomonas putida CBB5 uses caffeine as its only carbon and nitrogen source.</a:t>
             </a:r>
           </a:p>
         </p:txBody>
@@ -858,7 +858,7 @@
           <a:lstStyle/>
           <a:p>
             <a:r>
-              <a:t>Photo: assets/photo/hand-of-compost.jpg (Foundation library). Thermometer marks 55°C, from the slide text. Stickers (lemon, cup, beans, seedlings, bacteria, pH strip, thermometer) are drawn PowerPoint shapes, grouped and editable.</a:t>
+              <a:t>Photo: assets/photo/hand-of-compost.jpg (Foundation library). Thermometer marks 55°C, from the slide text. Stickers (lemon, cup, beans, seedlings, bacteria, pH strip, thermometer) are drawn PowerPoint shapes, grouped and editable. Draft livelier copy (not in use, awaiting approval): The fix: compost them first. 🔥 Grounds are a nitrogen-rich green. Mix them with woody browns like leaves or wood chips, and keep the pile hot: 55°C (131°F) or more.</a:t>
             </a:r>
           </a:p>
         </p:txBody>
@@ -928,7 +928,7 @@
           <a:lstStyle/>
           <a:p>
             <a:r>
-              <a:t>Sources slide.</a:t>
+              <a:t>Sources slide. Draft livelier copy (not in use, awaiting approval): Save this for your next coffee run. ☕</a:t>
             </a:r>
           </a:p>
         </p:txBody>
@@ -4018,7 +4018,7 @@
       </p:sp>
       <p:pic>
         <p:nvPicPr>
-          <p:cNvPr id="4" name="Picture 3" descr="4080242791985097375.jpg"/>
+          <p:cNvPr id="4" name="Picture 3" descr="528992742192131230.jpg"/>
           <p:cNvPicPr>
             <a:picLocks noChangeAspect="1"/>
           </p:cNvPicPr>
@@ -4177,7 +4177,7 @@
       </p:sp>
       <p:pic>
         <p:nvPicPr>
-          <p:cNvPr id="8" name="Picture 7" descr="7995214392566356973.jpg"/>
+          <p:cNvPr id="8" name="Picture 7" descr="1295611418783792776.jpg"/>
           <p:cNvPicPr>
             <a:picLocks noChangeAspect="1"/>
           </p:cNvPicPr>
@@ -5311,48 +5311,9 @@
           </a:p>
         </p:txBody>
       </p:sp>
-      <p:sp>
-        <p:nvSpPr>
-          <p:cNvPr id="35" name="TextBox 34"/>
-          <p:cNvSpPr txBox="1"/>
-          <p:nvPr/>
-        </p:nvSpPr>
-        <p:spPr>
-          <a:xfrm>
-            <a:off x="762000" y="11572875"/>
-            <a:ext cx="7429500" cy="952500"/>
-          </a:xfrm>
-          <a:prstGeom prst="rect">
-            <a:avLst/>
-          </a:prstGeom>
-          <a:noFill/>
-        </p:spPr>
-        <p:txBody>
-          <a:bodyPr wrap="square" lIns="0" rIns="0" tIns="0" bIns="0" anchor="ctr">
-            <a:spAutoFit/>
-          </a:bodyPr>
-          <a:lstStyle/>
-          <a:p>
-            <a:pPr algn="l">
-              <a:lnSpc>
-                <a:spcPct val="110000"/>
-              </a:lnSpc>
-            </a:pPr>
-            <a:r>
-              <a:rPr sz="3000" b="1" i="0">
-                <a:solidFill>
-                  <a:srgbClr val="22371F"/>
-                </a:solidFill>
-                <a:latin typeface="Source Sans 3"/>
-              </a:rPr>
-              <a:t>Happy International Coffee Day ☕ Let's spill the beans.</a:t>
-            </a:r>
-          </a:p>
-        </p:txBody>
-      </p:sp>
       <p:pic>
         <p:nvPicPr>
-          <p:cNvPr id="36" name="Picture 35" descr="foundation-logo-color.png"/>
+          <p:cNvPr id="35" name="Picture 34" descr="foundation-logo-color.png"/>
           <p:cNvPicPr>
             <a:picLocks noChangeAspect="1"/>
           </p:cNvPicPr>
@@ -5433,7 +5394,7 @@
         <p:spPr>
           <a:xfrm>
             <a:off x="762000" y="1047750"/>
-            <a:ext cx="8763000" cy="3156584"/>
+            <a:ext cx="8763000" cy="2136139"/>
           </a:xfrm>
           <a:prstGeom prst="rect">
             <a:avLst/>
@@ -5458,7 +5419,7 @@
                 </a:solidFill>
                 <a:latin typeface="Montserrat"/>
               </a:rPr>
-              <a:t>Plot twist: your coffee took the acid with it.</a:t>
+              <a:t>Brewing extracts most of the acids.</a:t>
             </a:r>
           </a:p>
         </p:txBody>
@@ -5471,8 +5432,8 @@
         </p:nvSpPr>
         <p:spPr>
           <a:xfrm>
-            <a:off x="762000" y="4356734"/>
-            <a:ext cx="8763000" cy="2266895"/>
+            <a:off x="762000" y="3336289"/>
+            <a:ext cx="8763000" cy="1771608"/>
           </a:xfrm>
           <a:prstGeom prst="rect">
             <a:avLst/>
@@ -5491,13 +5452,13 @@
               </a:lnSpc>
             </a:pPr>
             <a:r>
-              <a:rPr sz="3800" b="0" i="0">
+              <a:rPr sz="4400" b="0" i="0">
                 <a:solidFill>
                   <a:srgbClr val="333130"/>
                 </a:solidFill>
                 <a:latin typeface="Source Sans 3"/>
               </a:rPr>
-              <a:t>Brewing pulls most of the acids into your cup. The spent grounds left behind sit close to neutral pH.</a:t>
+              <a:t>Spent grounds sit close to neutral pH.</a:t>
             </a:r>
           </a:p>
         </p:txBody>
@@ -5510,7 +5471,7 @@
         </p:nvSpPr>
         <p:spPr>
           <a:xfrm>
-            <a:off x="723900" y="8776280"/>
+            <a:off x="723900" y="7260547"/>
             <a:ext cx="8839200" cy="1524000"/>
           </a:xfrm>
           <a:prstGeom prst="rect">
@@ -5560,7 +5521,7 @@
         </p:nvSpPr>
         <p:spPr>
           <a:xfrm>
-            <a:off x="857250" y="8909630"/>
+            <a:off x="857250" y="7393897"/>
             <a:ext cx="581025" cy="857250"/>
           </a:xfrm>
           <a:prstGeom prst="rect">
@@ -5604,7 +5565,7 @@
         </p:nvSpPr>
         <p:spPr>
           <a:xfrm>
-            <a:off x="1428750" y="8909630"/>
+            <a:off x="1428750" y="7393897"/>
             <a:ext cx="581025" cy="857250"/>
           </a:xfrm>
           <a:prstGeom prst="rect">
@@ -5648,7 +5609,7 @@
         </p:nvSpPr>
         <p:spPr>
           <a:xfrm>
-            <a:off x="2000250" y="8909630"/>
+            <a:off x="2000250" y="7393897"/>
             <a:ext cx="581025" cy="857250"/>
           </a:xfrm>
           <a:prstGeom prst="rect">
@@ -5692,7 +5653,7 @@
         </p:nvSpPr>
         <p:spPr>
           <a:xfrm>
-            <a:off x="2571750" y="8909630"/>
+            <a:off x="2571750" y="7393897"/>
             <a:ext cx="581025" cy="857250"/>
           </a:xfrm>
           <a:prstGeom prst="rect">
@@ -5736,7 +5697,7 @@
         </p:nvSpPr>
         <p:spPr>
           <a:xfrm>
-            <a:off x="3143250" y="8909630"/>
+            <a:off x="3143250" y="7393897"/>
             <a:ext cx="581025" cy="857250"/>
           </a:xfrm>
           <a:prstGeom prst="rect">
@@ -5780,7 +5741,7 @@
         </p:nvSpPr>
         <p:spPr>
           <a:xfrm>
-            <a:off x="3714750" y="8909630"/>
+            <a:off x="3714750" y="7393897"/>
             <a:ext cx="581025" cy="857250"/>
           </a:xfrm>
           <a:prstGeom prst="rect">
@@ -5824,7 +5785,7 @@
         </p:nvSpPr>
         <p:spPr>
           <a:xfrm>
-            <a:off x="4286250" y="8909630"/>
+            <a:off x="4286250" y="7393897"/>
             <a:ext cx="581025" cy="857250"/>
           </a:xfrm>
           <a:prstGeom prst="rect">
@@ -5868,7 +5829,7 @@
         </p:nvSpPr>
         <p:spPr>
           <a:xfrm>
-            <a:off x="4857750" y="8909630"/>
+            <a:off x="4857750" y="7393897"/>
             <a:ext cx="581025" cy="857250"/>
           </a:xfrm>
           <a:prstGeom prst="rect">
@@ -5912,7 +5873,7 @@
         </p:nvSpPr>
         <p:spPr>
           <a:xfrm>
-            <a:off x="5429250" y="8909630"/>
+            <a:off x="5429250" y="7393897"/>
             <a:ext cx="581025" cy="857250"/>
           </a:xfrm>
           <a:prstGeom prst="rect">
@@ -5956,7 +5917,7 @@
         </p:nvSpPr>
         <p:spPr>
           <a:xfrm>
-            <a:off x="6000750" y="8909630"/>
+            <a:off x="6000750" y="7393897"/>
             <a:ext cx="581025" cy="857250"/>
           </a:xfrm>
           <a:prstGeom prst="rect">
@@ -6000,7 +5961,7 @@
         </p:nvSpPr>
         <p:spPr>
           <a:xfrm>
-            <a:off x="6572250" y="8909630"/>
+            <a:off x="6572250" y="7393897"/>
             <a:ext cx="581025" cy="857250"/>
           </a:xfrm>
           <a:prstGeom prst="rect">
@@ -6044,7 +6005,7 @@
         </p:nvSpPr>
         <p:spPr>
           <a:xfrm>
-            <a:off x="7143750" y="8909630"/>
+            <a:off x="7143750" y="7393897"/>
             <a:ext cx="581025" cy="857250"/>
           </a:xfrm>
           <a:prstGeom prst="rect">
@@ -6088,7 +6049,7 @@
         </p:nvSpPr>
         <p:spPr>
           <a:xfrm>
-            <a:off x="7715250" y="8909630"/>
+            <a:off x="7715250" y="7393897"/>
             <a:ext cx="581025" cy="857250"/>
           </a:xfrm>
           <a:prstGeom prst="rect">
@@ -6132,7 +6093,7 @@
         </p:nvSpPr>
         <p:spPr>
           <a:xfrm>
-            <a:off x="8286750" y="8909630"/>
+            <a:off x="8286750" y="7393897"/>
             <a:ext cx="581025" cy="857250"/>
           </a:xfrm>
           <a:prstGeom prst="rect">
@@ -6176,7 +6137,7 @@
         </p:nvSpPr>
         <p:spPr>
           <a:xfrm>
-            <a:off x="8858250" y="8909630"/>
+            <a:off x="8858250" y="7393897"/>
             <a:ext cx="581025" cy="857250"/>
           </a:xfrm>
           <a:prstGeom prst="rect">
@@ -6220,7 +6181,7 @@
         </p:nvSpPr>
         <p:spPr>
           <a:xfrm>
-            <a:off x="666750" y="9824030"/>
+            <a:off x="666750" y="8308297"/>
             <a:ext cx="952500" cy="381000"/>
           </a:xfrm>
           <a:prstGeom prst="rect">
@@ -6259,7 +6220,7 @@
         </p:nvSpPr>
         <p:spPr>
           <a:xfrm>
-            <a:off x="4667250" y="9824030"/>
+            <a:off x="4667250" y="8308297"/>
             <a:ext cx="952500" cy="381000"/>
           </a:xfrm>
           <a:prstGeom prst="rect">
@@ -6298,7 +6259,7 @@
         </p:nvSpPr>
         <p:spPr>
           <a:xfrm>
-            <a:off x="8667750" y="9824030"/>
+            <a:off x="8667750" y="8308297"/>
             <a:ext cx="952500" cy="381000"/>
           </a:xfrm>
           <a:prstGeom prst="rect">
@@ -6338,9 +6299,9 @@
         <p:grpSpPr>
           <a:xfrm rot="21000000">
             <a:off x="0" y="0"/>
-            <a:ext cx="3186112" cy="8433380"/>
+            <a:ext cx="3186112" cy="6917647"/>
             <a:chOff x="0" y="0"/>
-            <a:chExt cx="3186112" cy="8433380"/>
+            <a:chExt cx="3186112" cy="6917647"/>
           </a:xfrm>
         </p:grpSpPr>
         <p:sp>
@@ -6351,7 +6312,7 @@
           </p:nvSpPr>
           <p:spPr>
             <a:xfrm rot="19500000">
-              <a:off x="2586037" y="6966530"/>
+              <a:off x="2586037" y="5450797"/>
               <a:ext cx="600075" cy="300037"/>
             </a:xfrm>
             <a:prstGeom prst="ellipse">
@@ -6397,7 +6358,7 @@
           </p:nvSpPr>
           <p:spPr>
             <a:xfrm>
-              <a:off x="1619250" y="7099880"/>
+              <a:off x="1619250" y="5584147"/>
               <a:ext cx="1333500" cy="1333500"/>
             </a:xfrm>
             <a:prstGeom prst="ellipse">
@@ -6449,7 +6410,7 @@
           </p:nvSpPr>
           <p:spPr>
             <a:xfrm>
-              <a:off x="1752600" y="7233230"/>
+              <a:off x="1752600" y="5717497"/>
               <a:ext cx="1066800" cy="1066800"/>
             </a:xfrm>
             <a:prstGeom prst="ellipse">
@@ -6493,7 +6454,7 @@
           </p:nvSpPr>
           <p:spPr>
             <a:xfrm>
-              <a:off x="1752600" y="7738055"/>
+              <a:off x="1752600" y="6222322"/>
               <a:ext cx="1066800" cy="57150"/>
             </a:xfrm>
             <a:prstGeom prst="rect">
@@ -6537,7 +6498,7 @@
           </p:nvSpPr>
           <p:spPr>
             <a:xfrm rot="2700000">
-              <a:off x="1752600" y="7738055"/>
+              <a:off x="1752600" y="6222322"/>
               <a:ext cx="1066800" cy="57150"/>
             </a:xfrm>
             <a:prstGeom prst="rect">
@@ -6581,7 +6542,7 @@
           </p:nvSpPr>
           <p:spPr>
             <a:xfrm rot="5400000">
-              <a:off x="1752600" y="7738055"/>
+              <a:off x="1752600" y="6222322"/>
               <a:ext cx="1066800" cy="57150"/>
             </a:xfrm>
             <a:prstGeom prst="rect">
@@ -6625,7 +6586,7 @@
           </p:nvSpPr>
           <p:spPr>
             <a:xfrm rot="8100000">
-              <a:off x="1752600" y="7738055"/>
+              <a:off x="1752600" y="6222322"/>
               <a:ext cx="1066800" cy="57150"/>
             </a:xfrm>
             <a:prstGeom prst="rect">
@@ -6669,7 +6630,7 @@
           </p:nvSpPr>
           <p:spPr>
             <a:xfrm>
-              <a:off x="2205990" y="7686620"/>
+              <a:off x="2205990" y="6170887"/>
               <a:ext cx="160020" cy="160020"/>
             </a:xfrm>
             <a:prstGeom prst="ellipse">
@@ -6714,7 +6675,7 @@
         </p:nvSpPr>
         <p:spPr>
           <a:xfrm rot="10800000">
-            <a:off x="2133600" y="8528630"/>
+            <a:off x="2133600" y="7012897"/>
             <a:ext cx="304800" cy="247650"/>
           </a:xfrm>
           <a:prstGeom prst="triangle">
@@ -6759,9 +6720,9 @@
         <p:grpSpPr>
           <a:xfrm>
             <a:off x="0" y="0"/>
-            <a:ext cx="5425440" cy="8494340"/>
+            <a:ext cx="5425440" cy="6978607"/>
             <a:chOff x="0" y="0"/>
-            <a:chExt cx="5425440" cy="8494340"/>
+            <a:chExt cx="5425440" cy="6978607"/>
           </a:xfrm>
         </p:grpSpPr>
         <p:sp>
@@ -6772,7 +6733,7 @@
           </p:nvSpPr>
           <p:spPr>
             <a:xfrm>
-              <a:off x="3733800" y="8098100"/>
+              <a:off x="3733800" y="6582367"/>
               <a:ext cx="1676400" cy="396240"/>
             </a:xfrm>
             <a:prstGeom prst="ellipse">
@@ -6824,7 +6785,7 @@
           </p:nvSpPr>
           <p:spPr>
             <a:xfrm>
-              <a:off x="4968240" y="7488500"/>
+              <a:off x="4968240" y="5972767"/>
               <a:ext cx="457200" cy="457200"/>
             </a:xfrm>
             <a:prstGeom prst="donut">
@@ -6870,7 +6831,7 @@
           </p:nvSpPr>
           <p:spPr>
             <a:xfrm>
-              <a:off x="3992880" y="7290380"/>
+              <a:off x="3992880" y="5774647"/>
               <a:ext cx="1158240" cy="944880"/>
             </a:xfrm>
             <a:prstGeom prst="roundRect">
@@ -6916,7 +6877,7 @@
           </p:nvSpPr>
           <p:spPr>
             <a:xfrm>
-              <a:off x="4021455" y="7854260"/>
+              <a:off x="4021455" y="6338527"/>
               <a:ext cx="1101090" cy="121920"/>
             </a:xfrm>
             <a:prstGeom prst="rect">
@@ -6960,7 +6921,7 @@
           </p:nvSpPr>
           <p:spPr>
             <a:xfrm>
-              <a:off x="4023360" y="7183700"/>
+              <a:off x="4023360" y="5667967"/>
               <a:ext cx="1097280" cy="243840"/>
             </a:xfrm>
             <a:prstGeom prst="ellipse">
@@ -7006,7 +6967,7 @@
           </p:nvSpPr>
           <p:spPr>
             <a:xfrm>
-              <a:off x="4406900" y="7611267"/>
+              <a:off x="4406900" y="6095534"/>
               <a:ext cx="59266" cy="59266"/>
             </a:xfrm>
             <a:prstGeom prst="ellipse">
@@ -7050,7 +7011,7 @@
           </p:nvSpPr>
           <p:spPr>
             <a:xfrm>
-              <a:off x="4677833" y="7611267"/>
+              <a:off x="4677833" y="6095534"/>
               <a:ext cx="59266" cy="59266"/>
             </a:xfrm>
             <a:prstGeom prst="ellipse">
@@ -7094,7 +7055,7 @@
           </p:nvSpPr>
           <p:spPr>
             <a:xfrm rot="10800000">
-              <a:off x="4478866" y="7657833"/>
+              <a:off x="4478866" y="6142101"/>
               <a:ext cx="186266" cy="135466"/>
             </a:xfrm>
             <a:prstGeom prst="blockArc">
@@ -7142,7 +7103,7 @@
           </p:nvSpPr>
           <p:spPr>
             <a:xfrm rot="5400000">
-              <a:off x="4282440" y="6726500"/>
+              <a:off x="4282440" y="5210767"/>
               <a:ext cx="91440" cy="365760"/>
             </a:xfrm>
             <a:prstGeom prst="wave">
@@ -7186,7 +7147,7 @@
           </p:nvSpPr>
           <p:spPr>
             <a:xfrm rot="5400000">
-              <a:off x="4526280" y="6726500"/>
+              <a:off x="4526280" y="5210767"/>
               <a:ext cx="91440" cy="365760"/>
             </a:xfrm>
             <a:prstGeom prst="wave">
@@ -7230,7 +7191,7 @@
           </p:nvSpPr>
           <p:spPr>
             <a:xfrm rot="5400000">
-              <a:off x="4770120" y="6726500"/>
+              <a:off x="4770120" y="5210767"/>
               <a:ext cx="91440" cy="365760"/>
             </a:xfrm>
             <a:prstGeom prst="wave">
@@ -7275,7 +7236,7 @@
         </p:nvSpPr>
         <p:spPr>
           <a:xfrm rot="10800000">
-            <a:off x="4419600" y="8528630"/>
+            <a:off x="4419600" y="7012897"/>
             <a:ext cx="304800" cy="247650"/>
           </a:xfrm>
           <a:prstGeom prst="triangle">
@@ -7697,7 +7658,7 @@
         <p:spPr>
           <a:xfrm>
             <a:off x="762000" y="1047750"/>
-            <a:ext cx="8763000" cy="2267810"/>
+            <a:ext cx="8763000" cy="2959079"/>
           </a:xfrm>
           <a:prstGeom prst="rect">
             <a:avLst/>
@@ -7716,13 +7677,13 @@
               </a:lnSpc>
             </a:pPr>
             <a:r>
-              <a:rPr sz="6600" b="1" i="0">
+              <a:rPr sz="5800" b="1" i="0">
                 <a:solidFill>
                   <a:srgbClr val="22371F"/>
                 </a:solidFill>
                 <a:latin typeface="Montserrat"/>
               </a:rPr>
-              <a:t>So what's the catch? Caffeine. 😬</a:t>
+              <a:t>The real issue: residual caffeine and chlorogenic acids.</a:t>
             </a:r>
           </a:p>
         </p:txBody>
@@ -7735,8 +7696,8 @@
         </p:nvSpPr>
         <p:spPr>
           <a:xfrm>
-            <a:off x="762000" y="3467960"/>
-            <a:ext cx="8763000" cy="2990777"/>
+            <a:off x="762000" y="4159229"/>
+            <a:ext cx="8763000" cy="1771608"/>
           </a:xfrm>
           <a:prstGeom prst="rect">
             <a:avLst/>
@@ -7755,13 +7716,13 @@
               </a:lnSpc>
             </a:pPr>
             <a:r>
-              <a:rPr sz="3800" b="0" i="0">
+              <a:rPr sz="4400" b="0" i="0">
                 <a:solidFill>
                   <a:srgbClr val="333130"/>
                 </a:solidFill>
                 <a:latin typeface="Source Sans 3"/>
               </a:rPr>
-              <a:t>Leftover caffeine and chlorogenic acids are allelopathic: plant-speak for chemicals that stop seeds sprouting and roots growing.</a:t>
+              <a:t>Both are allelopathic. They inhibit germination and root growth.</a:t>
             </a:r>
           </a:p>
         </p:txBody>
@@ -7774,8 +7735,8 @@
         </p:nvSpPr>
         <p:spPr>
           <a:xfrm rot="21360000">
-            <a:off x="857249" y="6096000"/>
-            <a:ext cx="4732020" cy="5071110"/>
+            <a:off x="857250" y="6667500"/>
+            <a:ext cx="4526280" cy="4872990"/>
           </a:xfrm>
           <a:prstGeom prst="rect">
             <a:avLst/>
@@ -7818,7 +7779,7 @@
       </p:sp>
       <p:pic>
         <p:nvPicPr>
-          <p:cNvPr id="6" name="Picture 5" descr="500543243627123432.jpg"/>
+          <p:cNvPr id="6" name="Picture 5" descr="2706250834023328548.jpg"/>
           <p:cNvPicPr>
             <a:picLocks noChangeAspect="1"/>
           </p:cNvPicPr>
@@ -7832,8 +7793,8 @@
         </p:blipFill>
         <p:spPr>
           <a:xfrm rot="21360000">
-            <a:off x="1020683" y="6271673"/>
-            <a:ext cx="4381500" cy="4381500"/>
+            <a:off x="1012797" y="6835562"/>
+            <a:ext cx="4191000" cy="4191000"/>
           </a:xfrm>
           <a:prstGeom prst="rect">
             <a:avLst/>
@@ -7848,8 +7809,8 @@
         </p:nvSpPr>
         <p:spPr>
           <a:xfrm rot="21360000">
-            <a:off x="1191441" y="10647209"/>
-            <a:ext cx="4381500" cy="514350"/>
+            <a:off x="1176911" y="11020831"/>
+            <a:ext cx="4191000" cy="514350"/>
           </a:xfrm>
           <a:prstGeom prst="rect">
             <a:avLst/>
@@ -7887,7 +7848,7 @@
         </p:nvSpPr>
         <p:spPr>
           <a:xfrm rot="19800000">
-            <a:off x="714375" y="5953125"/>
+            <a:off x="714375" y="6524625"/>
             <a:ext cx="1428750" cy="438150"/>
           </a:xfrm>
           <a:prstGeom prst="rect">
@@ -8440,9 +8401,9 @@
         <p:grpSpPr>
           <a:xfrm rot="480000">
             <a:off x="0" y="0"/>
-            <a:ext cx="9372600" cy="8010525"/>
+            <a:ext cx="9795510" cy="7006590"/>
             <a:chOff x="0" y="0"/>
-            <a:chExt cx="9372600" cy="8010525"/>
+            <a:chExt cx="9795510" cy="7006590"/>
           </a:xfrm>
         </p:grpSpPr>
         <p:sp>
@@ -8453,8 +8414,8 @@
           </p:nvSpPr>
           <p:spPr>
             <a:xfrm>
-              <a:off x="7786687" y="7639050"/>
-              <a:ext cx="1571625" cy="371475"/>
+              <a:off x="8315325" y="6659880"/>
+              <a:ext cx="1466850" cy="346710"/>
             </a:xfrm>
             <a:prstGeom prst="ellipse">
               <a:avLst/>
@@ -8505,8 +8466,8 @@
           </p:nvSpPr>
           <p:spPr>
             <a:xfrm>
-              <a:off x="8943975" y="7067550"/>
-              <a:ext cx="428625" cy="428625"/>
+              <a:off x="9395460" y="6126480"/>
+              <a:ext cx="400050" cy="400050"/>
             </a:xfrm>
             <a:prstGeom prst="donut">
               <a:avLst/>
@@ -8551,8 +8512,8 @@
           </p:nvSpPr>
           <p:spPr>
             <a:xfrm>
-              <a:off x="8029575" y="6881812"/>
-              <a:ext cx="1085850" cy="885825"/>
+              <a:off x="8542020" y="5953125"/>
+              <a:ext cx="1013460" cy="826770"/>
             </a:xfrm>
             <a:prstGeom prst="roundRect">
               <a:avLst/>
@@ -8597,8 +8558,8 @@
           </p:nvSpPr>
           <p:spPr>
             <a:xfrm>
-              <a:off x="8058150" y="7410450"/>
-              <a:ext cx="1028700" cy="114300"/>
+              <a:off x="8570595" y="6446520"/>
+              <a:ext cx="956310" cy="106680"/>
             </a:xfrm>
             <a:prstGeom prst="rect">
               <a:avLst/>
@@ -8641,8 +8602,8 @@
           </p:nvSpPr>
           <p:spPr>
             <a:xfrm>
-              <a:off x="8058150" y="6781800"/>
-              <a:ext cx="1028700" cy="228600"/>
+              <a:off x="8568690" y="5859780"/>
+              <a:ext cx="960120" cy="213360"/>
             </a:xfrm>
             <a:prstGeom prst="ellipse">
               <a:avLst/>
@@ -8687,8 +8648,8 @@
           </p:nvSpPr>
           <p:spPr>
             <a:xfrm rot="5400000">
-              <a:off x="8301037" y="6353175"/>
-              <a:ext cx="85725" cy="342900"/>
+              <a:off x="8795385" y="5459730"/>
+              <a:ext cx="80010" cy="320040"/>
             </a:xfrm>
             <a:prstGeom prst="wave">
               <a:avLst/>
@@ -8731,8 +8692,8 @@
           </p:nvSpPr>
           <p:spPr>
             <a:xfrm rot="5400000">
-              <a:off x="8529637" y="6353175"/>
-              <a:ext cx="85725" cy="342900"/>
+              <a:off x="9008745" y="5459730"/>
+              <a:ext cx="80010" cy="320040"/>
             </a:xfrm>
             <a:prstGeom prst="wave">
               <a:avLst/>
@@ -8775,8 +8736,8 @@
           </p:nvSpPr>
           <p:spPr>
             <a:xfrm rot="5400000">
-              <a:off x="8758237" y="6353175"/>
-              <a:ext cx="85725" cy="342900"/>
+              <a:off x="9222105" y="5459730"/>
+              <a:ext cx="80010" cy="320040"/>
             </a:xfrm>
             <a:prstGeom prst="wave">
               <a:avLst/>
@@ -8871,7 +8832,7 @@
         <p:spPr>
           <a:xfrm>
             <a:off x="762000" y="1047750"/>
-            <a:ext cx="8763000" cy="2267810"/>
+            <a:ext cx="8763000" cy="3913688"/>
           </a:xfrm>
           <a:prstGeom prst="rect">
             <a:avLst/>
@@ -8890,66 +8851,27 @@
               </a:lnSpc>
             </a:pPr>
             <a:r>
-              <a:rPr sz="6600" b="1" i="0">
+              <a:rPr sz="5800" b="1" i="0">
                 <a:solidFill>
                   <a:srgbClr val="22371F"/>
                 </a:solidFill>
                 <a:latin typeface="Montserrat"/>
               </a:rPr>
-              <a:t>Sprinkled straight on the garden?</a:t>
+              <a:t>Fresh grounds spread on beds have reduced plant growth in trials.</a:t>
             </a:r>
           </a:p>
         </p:txBody>
       </p:sp>
       <p:sp>
         <p:nvSpPr>
-          <p:cNvPr id="4" name="TextBox 3"/>
-          <p:cNvSpPr txBox="1"/>
-          <p:nvPr/>
-        </p:nvSpPr>
-        <p:spPr>
-          <a:xfrm>
-            <a:off x="762000" y="3467960"/>
-            <a:ext cx="8763000" cy="1543013"/>
-          </a:xfrm>
-          <a:prstGeom prst="rect">
-            <a:avLst/>
-          </a:prstGeom>
-          <a:noFill/>
-        </p:spPr>
-        <p:txBody>
-          <a:bodyPr wrap="square" lIns="0" rIns="0" tIns="0" bIns="0" anchor="t">
-            <a:spAutoFit/>
-          </a:bodyPr>
-          <a:lstStyle/>
-          <a:p>
-            <a:pPr algn="l">
-              <a:lnSpc>
-                <a:spcPct val="125000"/>
-              </a:lnSpc>
-            </a:pPr>
-            <a:r>
-              <a:rPr sz="3800" b="0" i="0">
-                <a:solidFill>
-                  <a:srgbClr val="333130"/>
-                </a:solidFill>
-                <a:latin typeface="Source Sans 3"/>
-              </a:rPr>
-              <a:t>In trials, fresh grounds spread on beds actually slowed plant growth. 🥀</a:t>
-            </a:r>
-          </a:p>
-        </p:txBody>
-      </p:sp>
-      <p:sp>
-        <p:nvSpPr>
-          <p:cNvPr id="5" name="Rectangle 4"/>
+          <p:cNvPr id="4" name="Rectangle 3"/>
           <p:cNvSpPr/>
           <p:nvPr/>
         </p:nvSpPr>
         <p:spPr>
           <a:xfrm rot="180000">
-            <a:off x="3143249" y="5334000"/>
-            <a:ext cx="5349240" cy="5695950"/>
+            <a:off x="3143250" y="5905500"/>
+            <a:ext cx="5143500" cy="5476875"/>
           </a:xfrm>
           <a:prstGeom prst="rect">
             <a:avLst/>
@@ -8992,7 +8914,7 @@
       </p:sp>
       <p:pic>
         <p:nvPicPr>
-          <p:cNvPr id="6" name="Picture 5" descr="7311567527219344018.jpg"/>
+          <p:cNvPr id="5" name="Picture 4" descr="2723930794202739989.jpg"/>
           <p:cNvPicPr>
             <a:picLocks noChangeAspect="1"/>
           </p:cNvPicPr>
@@ -9006,8 +8928,8 @@
         </p:blipFill>
         <p:spPr>
           <a:xfrm rot="180000">
-            <a:off x="3350442" y="5532357"/>
-            <a:ext cx="4953000" cy="4953000"/>
+            <a:off x="3342473" y="6096228"/>
+            <a:ext cx="4762500" cy="4762500"/>
           </a:xfrm>
           <a:prstGeom prst="rect">
             <a:avLst/>
@@ -9016,14 +8938,14 @@
       </p:pic>
       <p:sp>
         <p:nvSpPr>
-          <p:cNvPr id="7" name="TextBox 6"/>
+          <p:cNvPr id="6" name="TextBox 5"/>
           <p:cNvSpPr txBox="1"/>
           <p:nvPr/>
         </p:nvSpPr>
         <p:spPr>
           <a:xfrm rot="180000">
-            <a:off x="3206575" y="10481590"/>
-            <a:ext cx="4953000" cy="544830"/>
+            <a:off x="3204140" y="10855106"/>
+            <a:ext cx="4762500" cy="523875"/>
           </a:xfrm>
           <a:prstGeom prst="rect">
             <a:avLst/>
@@ -9055,13 +8977,13 @@
       </p:sp>
       <p:sp>
         <p:nvSpPr>
-          <p:cNvPr id="8" name="Rectangle 7"/>
+          <p:cNvPr id="7" name="Rectangle 6"/>
           <p:cNvSpPr/>
           <p:nvPr/>
         </p:nvSpPr>
         <p:spPr>
           <a:xfrm rot="1800000">
-            <a:off x="7206615" y="5210175"/>
+            <a:off x="7000875" y="5781675"/>
             <a:ext cx="1428750" cy="438150"/>
           </a:xfrm>
           <a:prstGeom prst="rect">
@@ -9101,13 +9023,13 @@
       </p:sp>
       <p:sp>
         <p:nvSpPr>
-          <p:cNvPr id="9" name="Rectangle 8"/>
+          <p:cNvPr id="8" name="Rectangle 7"/>
           <p:cNvSpPr/>
           <p:nvPr/>
         </p:nvSpPr>
         <p:spPr>
           <a:xfrm rot="19800000">
-            <a:off x="3000375" y="5210175"/>
+            <a:off x="3000375" y="5781675"/>
             <a:ext cx="1428750" cy="438150"/>
           </a:xfrm>
           <a:prstGeom prst="rect">
@@ -9147,7 +9069,7 @@
       </p:sp>
       <p:grpSp>
         <p:nvGrpSpPr>
-          <p:cNvPr id="10" name="Group 9"/>
+          <p:cNvPr id="9" name="Group 8"/>
           <p:cNvGrpSpPr/>
           <p:nvPr/>
         </p:nvGrpSpPr>
@@ -9161,7 +9083,7 @@
         </p:grpSpPr>
         <p:sp>
           <p:nvSpPr>
-            <p:cNvPr id="11" name="Rectangle 10"/>
+            <p:cNvPr id="10" name="Rectangle 9"/>
             <p:cNvSpPr/>
             <p:nvPr/>
           </p:nvSpPr>
@@ -9205,7 +9127,7 @@
         </p:sp>
         <p:sp>
           <p:nvSpPr>
-            <p:cNvPr id="12" name="Oval 11"/>
+            <p:cNvPr id="11" name="Oval 10"/>
             <p:cNvSpPr/>
             <p:nvPr/>
           </p:nvSpPr>
@@ -9251,7 +9173,7 @@
         </p:sp>
         <p:sp>
           <p:nvSpPr>
-            <p:cNvPr id="13" name="Oval 12"/>
+            <p:cNvPr id="12" name="Oval 11"/>
             <p:cNvSpPr/>
             <p:nvPr/>
           </p:nvSpPr>
@@ -9297,7 +9219,7 @@
         </p:sp>
         <p:sp>
           <p:nvSpPr>
-            <p:cNvPr id="14" name="Oval 13"/>
+            <p:cNvPr id="13" name="Oval 12"/>
             <p:cNvSpPr/>
             <p:nvPr/>
           </p:nvSpPr>
@@ -9350,7 +9272,7 @@
       </p:grpSp>
       <p:grpSp>
         <p:nvGrpSpPr>
-          <p:cNvPr id="15" name="Group 14"/>
+          <p:cNvPr id="14" name="Group 13"/>
           <p:cNvGrpSpPr/>
           <p:nvPr/>
         </p:nvGrpSpPr>
@@ -9364,7 +9286,7 @@
         </p:grpSpPr>
         <p:sp>
           <p:nvSpPr>
-            <p:cNvPr id="16" name="Oval 15"/>
+            <p:cNvPr id="15" name="Oval 14"/>
             <p:cNvSpPr/>
             <p:nvPr/>
           </p:nvSpPr>
@@ -9416,7 +9338,7 @@
         </p:sp>
         <p:sp>
           <p:nvSpPr>
-            <p:cNvPr id="17" name="Rectangle 16"/>
+            <p:cNvPr id="16" name="Rectangle 15"/>
             <p:cNvSpPr/>
             <p:nvPr/>
           </p:nvSpPr>
@@ -9460,7 +9382,7 @@
         </p:sp>
         <p:sp>
           <p:nvSpPr>
-            <p:cNvPr id="18" name="Oval 17"/>
+            <p:cNvPr id="17" name="Oval 16"/>
             <p:cNvSpPr/>
             <p:nvPr/>
           </p:nvSpPr>
@@ -9512,7 +9434,7 @@
         </p:sp>
         <p:sp>
           <p:nvSpPr>
-            <p:cNvPr id="19" name="Rectangle 18"/>
+            <p:cNvPr id="18" name="Rectangle 17"/>
             <p:cNvSpPr/>
             <p:nvPr/>
           </p:nvSpPr>
@@ -9556,7 +9478,7 @@
         </p:sp>
         <p:sp>
           <p:nvSpPr>
-            <p:cNvPr id="20" name="Oval 19"/>
+            <p:cNvPr id="19" name="Oval 18"/>
             <p:cNvSpPr/>
             <p:nvPr/>
           </p:nvSpPr>
@@ -9608,7 +9530,7 @@
         </p:sp>
         <p:sp>
           <p:nvSpPr>
-            <p:cNvPr id="21" name="Rectangle 20"/>
+            <p:cNvPr id="20" name="Rectangle 19"/>
             <p:cNvSpPr/>
             <p:nvPr/>
           </p:nvSpPr>
@@ -9653,7 +9575,7 @@
       </p:grpSp>
       <p:grpSp>
         <p:nvGrpSpPr>
-          <p:cNvPr id="22" name="Group 21"/>
+          <p:cNvPr id="21" name="Group 20"/>
           <p:cNvGrpSpPr/>
           <p:nvPr/>
         </p:nvGrpSpPr>
@@ -9667,7 +9589,7 @@
         </p:grpSpPr>
         <p:sp>
           <p:nvSpPr>
-            <p:cNvPr id="23" name="Oval 22"/>
+            <p:cNvPr id="22" name="Oval 21"/>
             <p:cNvSpPr/>
             <p:nvPr/>
           </p:nvSpPr>
@@ -9719,7 +9641,7 @@
         </p:sp>
         <p:sp>
           <p:nvSpPr>
-            <p:cNvPr id="24" name="Donut 23"/>
+            <p:cNvPr id="23" name="Donut 22"/>
             <p:cNvSpPr/>
             <p:nvPr/>
           </p:nvSpPr>
@@ -9765,7 +9687,7 @@
         </p:sp>
         <p:sp>
           <p:nvSpPr>
-            <p:cNvPr id="25" name="Rounded Rectangle 24"/>
+            <p:cNvPr id="24" name="Rounded Rectangle 23"/>
             <p:cNvSpPr/>
             <p:nvPr/>
           </p:nvSpPr>
@@ -9811,7 +9733,7 @@
         </p:sp>
         <p:sp>
           <p:nvSpPr>
-            <p:cNvPr id="26" name="Rectangle 25"/>
+            <p:cNvPr id="25" name="Rectangle 24"/>
             <p:cNvSpPr/>
             <p:nvPr/>
           </p:nvSpPr>
@@ -9855,7 +9777,7 @@
         </p:sp>
         <p:sp>
           <p:nvSpPr>
-            <p:cNvPr id="27" name="Oval 26"/>
+            <p:cNvPr id="26" name="Oval 25"/>
             <p:cNvSpPr/>
             <p:nvPr/>
           </p:nvSpPr>
@@ -9901,7 +9823,7 @@
         </p:sp>
         <p:sp>
           <p:nvSpPr>
-            <p:cNvPr id="28" name="Wave 27"/>
+            <p:cNvPr id="27" name="Wave 26"/>
             <p:cNvSpPr/>
             <p:nvPr/>
           </p:nvSpPr>
@@ -9945,7 +9867,7 @@
         </p:sp>
         <p:sp>
           <p:nvSpPr>
-            <p:cNvPr id="29" name="Wave 28"/>
+            <p:cNvPr id="28" name="Wave 27"/>
             <p:cNvSpPr/>
             <p:nvPr/>
           </p:nvSpPr>
@@ -9989,7 +9911,7 @@
         </p:sp>
         <p:sp>
           <p:nvSpPr>
-            <p:cNvPr id="30" name="Wave 29"/>
+            <p:cNvPr id="29" name="Wave 28"/>
             <p:cNvSpPr/>
             <p:nvPr/>
           </p:nvSpPr>
@@ -10134,7 +10056,7 @@
       </p:sp>
       <p:pic>
         <p:nvPicPr>
-          <p:cNvPr id="4" name="Picture 3" descr="3989643155962724162.jpg"/>
+          <p:cNvPr id="4" name="Picture 3" descr="3828914008883886623.jpg"/>
           <p:cNvPicPr>
             <a:picLocks noChangeAspect="1"/>
           </p:cNvPicPr>
@@ -11563,8 +11485,8 @@
         </p:nvSpPr>
         <p:spPr>
           <a:xfrm>
-            <a:off x="762000" y="7334250"/>
-            <a:ext cx="8763000" cy="2070304"/>
+            <a:off x="762000" y="7524750"/>
+            <a:ext cx="8763000" cy="2136139"/>
           </a:xfrm>
           <a:prstGeom prst="rect">
             <a:avLst/>
@@ -11583,13 +11505,13 @@
               </a:lnSpc>
             </a:pPr>
             <a:r>
-              <a:rPr sz="6000" b="1" i="0">
+              <a:rPr sz="6200" b="1" i="0">
                 <a:solidFill>
                   <a:srgbClr val="22371F"/>
                 </a:solidFill>
                 <a:latin typeface="Montserrat"/>
               </a:rPr>
-              <a:t>Enter the compost crew. 🦠</a:t>
+              <a:t>Composting breaks them down.</a:t>
             </a:r>
           </a:p>
         </p:txBody>
@@ -11602,8 +11524,8 @@
         </p:nvSpPr>
         <p:spPr>
           <a:xfrm>
-            <a:off x="762000" y="9556954"/>
-            <a:ext cx="8763000" cy="2838381"/>
+            <a:off x="762000" y="9813289"/>
+            <a:ext cx="8763000" cy="2495489"/>
           </a:xfrm>
           <a:prstGeom prst="rect">
             <a:avLst/>
@@ -11622,13 +11544,13 @@
               </a:lnSpc>
             </a:pPr>
             <a:r>
-              <a:rPr sz="3600" b="0" i="0">
+              <a:rPr sz="4200" b="0" i="0">
                 <a:solidFill>
                   <a:srgbClr val="333130"/>
                 </a:solidFill>
                 <a:latin typeface="Source Sans 3"/>
               </a:rPr>
-              <a:t>Composting breaks caffeine down. Some soil bacteria eat it for breakfast, lunch and dinner: Pseudomonas putida CBB5 uses caffeine as its only carbon and nitrogen source.</a:t>
+              <a:t>Some soil bacteria, like Pseudomonas putida CBB5, use caffeine as their only carbon and nitrogen source.</a:t>
             </a:r>
           </a:p>
         </p:txBody>
@@ -11692,7 +11614,7 @@
         <p:spPr>
           <a:xfrm>
             <a:off x="762000" y="1047750"/>
-            <a:ext cx="8763000" cy="2267810"/>
+            <a:ext cx="8763000" cy="3156584"/>
           </a:xfrm>
           <a:prstGeom prst="rect">
             <a:avLst/>
@@ -11711,13 +11633,13 @@
               </a:lnSpc>
             </a:pPr>
             <a:r>
-              <a:rPr sz="6600" b="1" i="0">
+              <a:rPr sz="6200" b="1" i="0">
                 <a:solidFill>
                   <a:srgbClr val="22371F"/>
                 </a:solidFill>
                 <a:latin typeface="Montserrat"/>
               </a:rPr>
-              <a:t>The fix: compost them first. 🔥</a:t>
+              <a:t>Grounds are a green, nitrogen-rich input.</a:t>
             </a:r>
           </a:p>
         </p:txBody>
@@ -11730,8 +11652,8 @@
         </p:nvSpPr>
         <p:spPr>
           <a:xfrm>
-            <a:off x="762000" y="3467960"/>
-            <a:ext cx="8763000" cy="2990777"/>
+            <a:off x="762000" y="4356734"/>
+            <a:ext cx="8763000" cy="1771608"/>
           </a:xfrm>
           <a:prstGeom prst="rect">
             <a:avLst/>
@@ -11750,13 +11672,13 @@
               </a:lnSpc>
             </a:pPr>
             <a:r>
-              <a:rPr sz="3800" b="0" i="0">
+              <a:rPr sz="4400" b="0" i="0">
                 <a:solidFill>
                   <a:srgbClr val="333130"/>
                 </a:solidFill>
                 <a:latin typeface="Source Sans 3"/>
               </a:rPr>
-              <a:t>Grounds are a nitrogen-rich green. Mix them with woody browns like leaves or wood chips, and keep the pile hot: 55°C (131°F) or more.</a:t>
+              <a:t>Mix with woody browns and compost them hot, at 55°C or more.</a:t>
             </a:r>
           </a:p>
         </p:txBody>
@@ -11813,7 +11735,7 @@
       </p:sp>
       <p:pic>
         <p:nvPicPr>
-          <p:cNvPr id="6" name="Picture 5" descr="6447911635842332023.jpg"/>
+          <p:cNvPr id="6" name="Picture 5" descr="5435852472096531304.jpg"/>
           <p:cNvPicPr>
             <a:picLocks noChangeAspect="1"/>
           </p:cNvPicPr>
@@ -13006,48 +12928,9 @@
           </a:p>
         </p:txBody>
       </p:sp>
-      <p:sp>
-        <p:nvSpPr>
-          <p:cNvPr id="10" name="TextBox 9"/>
-          <p:cNvSpPr txBox="1"/>
-          <p:nvPr/>
-        </p:nvSpPr>
-        <p:spPr>
-          <a:xfrm>
-            <a:off x="762000" y="9191625"/>
-            <a:ext cx="8763000" cy="666750"/>
-          </a:xfrm>
-          <a:prstGeom prst="rect">
-            <a:avLst/>
-          </a:prstGeom>
-          <a:noFill/>
-        </p:spPr>
-        <p:txBody>
-          <a:bodyPr wrap="square" lIns="0" rIns="0" tIns="0" bIns="0" anchor="ctr">
-            <a:spAutoFit/>
-          </a:bodyPr>
-          <a:lstStyle/>
-          <a:p>
-            <a:pPr algn="l">
-              <a:lnSpc>
-                <a:spcPct val="120000"/>
-              </a:lnSpc>
-            </a:pPr>
-            <a:r>
-              <a:rPr sz="3600" b="1" i="0">
-                <a:solidFill>
-                  <a:srgbClr val="22371F"/>
-                </a:solidFill>
-                <a:latin typeface="Montserrat"/>
-              </a:rPr>
-              <a:t>Save this for your next coffee run. ☕</a:t>
-            </a:r>
-          </a:p>
-        </p:txBody>
-      </p:sp>
       <p:grpSp>
         <p:nvGrpSpPr>
-          <p:cNvPr id="11" name="Group 10"/>
+          <p:cNvPr id="10" name="Group 9"/>
           <p:cNvGrpSpPr/>
           <p:nvPr/>
         </p:nvGrpSpPr>
@@ -13061,7 +12944,7 @@
         </p:grpSpPr>
         <p:sp>
           <p:nvSpPr>
-            <p:cNvPr id="12" name="Oval 11"/>
+            <p:cNvPr id="11" name="Oval 10"/>
             <p:cNvSpPr/>
             <p:nvPr/>
           </p:nvSpPr>
@@ -13107,7 +12990,7 @@
         </p:sp>
         <p:sp>
           <p:nvSpPr>
-            <p:cNvPr id="13" name="Oval 12"/>
+            <p:cNvPr id="12" name="Oval 11"/>
             <p:cNvSpPr/>
             <p:nvPr/>
           </p:nvSpPr>
@@ -13159,7 +13042,7 @@
         </p:sp>
         <p:sp>
           <p:nvSpPr>
-            <p:cNvPr id="14" name="Oval 13"/>
+            <p:cNvPr id="13" name="Oval 12"/>
             <p:cNvSpPr/>
             <p:nvPr/>
           </p:nvSpPr>
@@ -13203,7 +13086,7 @@
         </p:sp>
         <p:sp>
           <p:nvSpPr>
-            <p:cNvPr id="15" name="Rectangle 14"/>
+            <p:cNvPr id="14" name="Rectangle 13"/>
             <p:cNvSpPr/>
             <p:nvPr/>
           </p:nvSpPr>
@@ -13247,7 +13130,7 @@
         </p:sp>
         <p:sp>
           <p:nvSpPr>
-            <p:cNvPr id="16" name="Rectangle 15"/>
+            <p:cNvPr id="15" name="Rectangle 14"/>
             <p:cNvSpPr/>
             <p:nvPr/>
           </p:nvSpPr>
@@ -13291,7 +13174,7 @@
         </p:sp>
         <p:sp>
           <p:nvSpPr>
-            <p:cNvPr id="17" name="Rectangle 16"/>
+            <p:cNvPr id="16" name="Rectangle 15"/>
             <p:cNvSpPr/>
             <p:nvPr/>
           </p:nvSpPr>
@@ -13335,7 +13218,7 @@
         </p:sp>
         <p:sp>
           <p:nvSpPr>
-            <p:cNvPr id="18" name="Rectangle 17"/>
+            <p:cNvPr id="17" name="Rectangle 16"/>
             <p:cNvSpPr/>
             <p:nvPr/>
           </p:nvSpPr>
@@ -13379,7 +13262,7 @@
         </p:sp>
         <p:sp>
           <p:nvSpPr>
-            <p:cNvPr id="19" name="Oval 18"/>
+            <p:cNvPr id="18" name="Oval 17"/>
             <p:cNvSpPr/>
             <p:nvPr/>
           </p:nvSpPr>
@@ -13424,7 +13307,7 @@
       </p:grpSp>
       <p:grpSp>
         <p:nvGrpSpPr>
-          <p:cNvPr id="20" name="Group 19"/>
+          <p:cNvPr id="19" name="Group 18"/>
           <p:cNvGrpSpPr/>
           <p:nvPr/>
         </p:nvGrpSpPr>
@@ -13438,7 +13321,7 @@
         </p:grpSpPr>
         <p:sp>
           <p:nvSpPr>
-            <p:cNvPr id="21" name="Oval 20"/>
+            <p:cNvPr id="20" name="Oval 19"/>
             <p:cNvSpPr/>
             <p:nvPr/>
           </p:nvSpPr>
@@ -13490,7 +13373,7 @@
         </p:sp>
         <p:sp>
           <p:nvSpPr>
-            <p:cNvPr id="22" name="Donut 21"/>
+            <p:cNvPr id="21" name="Donut 20"/>
             <p:cNvSpPr/>
             <p:nvPr/>
           </p:nvSpPr>
@@ -13536,7 +13419,7 @@
         </p:sp>
         <p:sp>
           <p:nvSpPr>
-            <p:cNvPr id="23" name="Rounded Rectangle 22"/>
+            <p:cNvPr id="22" name="Rounded Rectangle 21"/>
             <p:cNvSpPr/>
             <p:nvPr/>
           </p:nvSpPr>
@@ -13582,7 +13465,7 @@
         </p:sp>
         <p:sp>
           <p:nvSpPr>
-            <p:cNvPr id="24" name="Rectangle 23"/>
+            <p:cNvPr id="23" name="Rectangle 22"/>
             <p:cNvSpPr/>
             <p:nvPr/>
           </p:nvSpPr>
@@ -13626,7 +13509,7 @@
         </p:sp>
         <p:sp>
           <p:nvSpPr>
-            <p:cNvPr id="25" name="Oval 24"/>
+            <p:cNvPr id="24" name="Oval 23"/>
             <p:cNvSpPr/>
             <p:nvPr/>
           </p:nvSpPr>
@@ -13672,7 +13555,7 @@
         </p:sp>
         <p:sp>
           <p:nvSpPr>
-            <p:cNvPr id="26" name="Oval 25"/>
+            <p:cNvPr id="25" name="Oval 24"/>
             <p:cNvSpPr/>
             <p:nvPr/>
           </p:nvSpPr>
@@ -13716,7 +13599,7 @@
         </p:sp>
         <p:sp>
           <p:nvSpPr>
-            <p:cNvPr id="27" name="Oval 26"/>
+            <p:cNvPr id="26" name="Oval 25"/>
             <p:cNvSpPr/>
             <p:nvPr/>
           </p:nvSpPr>
@@ -13760,7 +13643,7 @@
         </p:sp>
         <p:sp>
           <p:nvSpPr>
-            <p:cNvPr id="28" name="Block Arc 27"/>
+            <p:cNvPr id="27" name="Block Arc 26"/>
             <p:cNvSpPr/>
             <p:nvPr/>
           </p:nvSpPr>
@@ -13808,7 +13691,7 @@
         </p:sp>
         <p:sp>
           <p:nvSpPr>
-            <p:cNvPr id="29" name="Wave 28"/>
+            <p:cNvPr id="28" name="Wave 27"/>
             <p:cNvSpPr/>
             <p:nvPr/>
           </p:nvSpPr>
@@ -13852,7 +13735,7 @@
         </p:sp>
         <p:sp>
           <p:nvSpPr>
-            <p:cNvPr id="30" name="Wave 29"/>
+            <p:cNvPr id="29" name="Wave 28"/>
             <p:cNvSpPr/>
             <p:nvPr/>
           </p:nvSpPr>
@@ -13896,7 +13779,7 @@
         </p:sp>
         <p:sp>
           <p:nvSpPr>
-            <p:cNvPr id="31" name="Wave 30"/>
+            <p:cNvPr id="30" name="Wave 29"/>
             <p:cNvSpPr/>
             <p:nvPr/>
           </p:nvSpPr>
@@ -13941,7 +13824,7 @@
       </p:grpSp>
       <p:grpSp>
         <p:nvGrpSpPr>
-          <p:cNvPr id="32" name="Group 31"/>
+          <p:cNvPr id="31" name="Group 30"/>
           <p:cNvGrpSpPr/>
           <p:nvPr/>
         </p:nvGrpSpPr>
@@ -13955,7 +13838,7 @@
         </p:grpSpPr>
         <p:sp>
           <p:nvSpPr>
-            <p:cNvPr id="33" name="Arc 32"/>
+            <p:cNvPr id="32" name="Arc 31"/>
             <p:cNvSpPr/>
             <p:nvPr/>
           </p:nvSpPr>
@@ -13999,7 +13882,7 @@
         </p:sp>
         <p:sp>
           <p:nvSpPr>
-            <p:cNvPr id="34" name="Arc 33"/>
+            <p:cNvPr id="33" name="Arc 32"/>
             <p:cNvSpPr/>
             <p:nvPr/>
           </p:nvSpPr>
@@ -14043,7 +13926,7 @@
         </p:sp>
         <p:sp>
           <p:nvSpPr>
-            <p:cNvPr id="35" name="Arc 34"/>
+            <p:cNvPr id="34" name="Arc 33"/>
             <p:cNvSpPr/>
             <p:nvPr/>
           </p:nvSpPr>
@@ -14087,7 +13970,7 @@
         </p:sp>
         <p:sp>
           <p:nvSpPr>
-            <p:cNvPr id="36" name="Rounded Rectangle 35"/>
+            <p:cNvPr id="35" name="Rounded Rectangle 34"/>
             <p:cNvSpPr/>
             <p:nvPr/>
           </p:nvSpPr>
@@ -14141,7 +14024,7 @@
         </p:sp>
         <p:sp>
           <p:nvSpPr>
-            <p:cNvPr id="37" name="Oval 36"/>
+            <p:cNvPr id="36" name="Oval 35"/>
             <p:cNvSpPr/>
             <p:nvPr/>
           </p:nvSpPr>
@@ -14185,7 +14068,7 @@
         </p:sp>
         <p:sp>
           <p:nvSpPr>
-            <p:cNvPr id="38" name="Oval 37"/>
+            <p:cNvPr id="37" name="Oval 36"/>
             <p:cNvSpPr/>
             <p:nvPr/>
           </p:nvSpPr>
@@ -14229,7 +14112,7 @@
         </p:sp>
         <p:sp>
           <p:nvSpPr>
-            <p:cNvPr id="39" name="Block Arc 38"/>
+            <p:cNvPr id="38" name="Block Arc 37"/>
             <p:cNvSpPr/>
             <p:nvPr/>
           </p:nvSpPr>
@@ -14278,7 +14161,7 @@
       </p:grpSp>
       <p:pic>
         <p:nvPicPr>
-          <p:cNvPr id="40" name="Picture 39" descr="trim-dried-flowers-2-1.png"/>
+          <p:cNvPr id="39" name="Picture 38" descr="trim-dried-flowers-2-1.png"/>
           <p:cNvPicPr>
             <a:picLocks noChangeAspect="1"/>
           </p:cNvPicPr>
@@ -14302,7 +14185,7 @@
       </p:pic>
       <p:pic>
         <p:nvPicPr>
-          <p:cNvPr id="41" name="Picture 40" descr="foundation-logo-color.png"/>
+          <p:cNvPr id="40" name="Picture 39" descr="foundation-logo-color.png"/>
           <p:cNvPicPr>
             <a:picLocks noChangeAspect="1"/>
           </p:cNvPicPr>

</xml_diff>